<commit_message>
ASTRO poster: fix formatting (font, overlaps, layout), formal prose, add PDF
Addresses review feedback on the first pass:
- Font: use concrete Calibri everywhere (prior pass set the theme token "+mn-lt"
  as a literal font name -> rendered wrong).
- Overlaps: explicit fit-checked font sizes (originals were 32-36pt and overflowed)
  + shrink-to-fit backstop; text no longer collides.
- Figures: clean non-overlapping stack in the results column with preserved aspect
  ratios (Fig1 examples, Fig2 threshold curve, Fig3 dose maps); captions repositioned
  directly beneath each.
- "METHODS AND MATERIALS" header overran its box -> shortened to "METHODS".
- Language: rewritten in formal scientific prose (Purpose/Methods/Results/
  Conclusions; no conversational phrasing).
- Added ASTRO_79011_poster.pdf (rendered) + refreshed preview PNG.

Verified via high-res Quick Look render.

Co-Authored-By: Claude Opus 4.8 <noreply@anthropic.com>
</commit_message>
<xml_diff>
--- a/reports/report2_ct_perturbation/astro_poster/ASTRO_79011_poster.pptx
+++ b/reports/report2_ct_perturbation/astro_poster/ASTRO_79011_poster.pptx
@@ -4941,7 +4941,9 @@
           </a:extLst>
         </p:spPr>
         <p:txBody>
-          <a:bodyPr lIns="419070" tIns="838139" rIns="419070" bIns="419070" anchor="ctr" anchorCtr="1"/>
+          <a:bodyPr lIns="419070" tIns="838139" rIns="419070" bIns="419070" anchor="ctr" anchorCtr="1" wrap="square">
+            <a:normAutofit/>
+          </a:bodyPr>
           <a:lstStyle>
             <a:lvl1pPr defTabSz="4022725">
               <a:defRPr>
@@ -5041,20 +5043,29 @@
             </a:lvl9pPr>
           </a:lstStyle>
           <a:p>
-            <a:pPr lvl="0" algn="ctr"/>
-            <a:r>
-              <a:rPr sz="4800">
+            <a:pPr lvl="0" algn="ctr">
+              <a:spcAft>
+                <a:spcPts val="600"/>
+              </a:spcAft>
+            </a:pPr>
+            <a:r>
+              <a:rPr sz="3400">
                 <a:latin typeface="Calibri"/>
               </a:rPr>
               <a:t>Neil Tripathi¹, Rahim Chowdhury², Lei Ren³, Amit Sawant³, Birjoo Vaishnav³</a:t>
             </a:r>
           </a:p>
           <a:p>
-            <a:r>
-              <a:rPr sz="4800">
+            <a:pPr>
+              <a:spcAft>
+                <a:spcPts val="600"/>
+              </a:spcAft>
+            </a:pPr>
+            <a:r>
+              <a:rPr sz="3400">
                 <a:latin typeface="Calibri"/>
               </a:rPr>
-              <a:t>¹New York University   ²UMD St. Joseph Medical Center   ³University of Maryland School of Medicine, Dept. of Radiation Oncology</a:t>
+              <a:t>¹New York University    ²UMD St. Joseph Medical Center    ³University of Maryland School of Medicine, Department of Radiation Oncology</a:t>
             </a:r>
           </a:p>
         </p:txBody>
@@ -5728,8 +5739,8 @@
         </p:nvSpPr>
         <p:spPr bwMode="auto">
           <a:xfrm>
-            <a:off x="18784113" y="20665440"/>
-            <a:ext cx="14720535" cy="1931292"/>
+            <a:off x="18836640" y="17612161"/>
+            <a:ext cx="14630400" cy="1554480"/>
           </a:xfrm>
           <a:prstGeom prst="rect">
             <a:avLst/>
@@ -5770,7 +5781,7 @@
         </p:spPr>
         <p:txBody>
           <a:bodyPr wrap="square" lIns="83814" tIns="41907" rIns="83814" bIns="41907">
-            <a:spAutoFit/>
+            <a:normAutofit/>
           </a:bodyPr>
           <a:lstStyle>
             <a:lvl1pPr defTabSz="4022725">
@@ -5871,11 +5882,16 @@
             </a:lvl9pPr>
           </a:lstStyle>
           <a:p>
-            <a:r>
-              <a:rPr sz="2400">
+            <a:pPr>
+              <a:spcAft>
+                <a:spcPts val="600"/>
+              </a:spcAft>
+            </a:pPr>
+            <a:r>
+              <a:rPr sz="1800">
                 <a:latin typeface="Calibri"/>
               </a:rPr>
-              <a:t>Figure 1. Example CT slices for one patient: original and each perturbation family at a mid severity (top), with difference-from-original maps (bottom). Resolution loss visibly blurs tissue boundaries; intensity perturbations leave structure edges intact.</a:t>
+              <a:t>Figure 1. Representative axial CT for one patient: unperturbed image and each perturbation family at intermediate severity (top row), with corresponding difference maps (bottom row). Spatial-resolution loss visibly blurs tissue boundaries, whereas intensity-based perturbations preserve structural edges.</a:t>
             </a:r>
           </a:p>
         </p:txBody>
@@ -6095,7 +6111,9 @@
           </a:extLst>
         </p:spPr>
         <p:txBody>
-          <a:bodyPr wrap="none" lIns="209535" tIns="209535" rIns="209535" bIns="209535" anchor="ctr" anchorCtr="1"/>
+          <a:bodyPr wrap="square" lIns="209535" tIns="209535" rIns="209535" bIns="209535" anchor="ctr" anchorCtr="1">
+            <a:normAutofit/>
+          </a:bodyPr>
           <a:lstStyle>
             <a:lvl1pPr defTabSz="4022725">
               <a:defRPr>
@@ -6195,16 +6213,16 @@
             </a:lvl9pPr>
           </a:lstStyle>
           <a:p>
-            <a:r>
-              <a:rPr lang="en-US" sz="5400" b="1" dirty="0">
-                <a:solidFill>
-                  <a:schemeClr val="accent1">
-                    <a:lumMod val="50000"/>
-                  </a:schemeClr>
-                </a:solidFill>
-                <a:latin typeface="Calibri" pitchFamily="34" charset="0"/>
+            <a:pPr>
+              <a:spcAft>
+                <a:spcPts val="600"/>
+              </a:spcAft>
+            </a:pPr>
+            <a:r>
+              <a:rPr sz="5400" b="1">
+                <a:latin typeface="Calibri"/>
               </a:rPr>
-              <a:t>METHODS AND MATERIALS</a:t>
+              <a:t>METHODS</a:t>
             </a:r>
           </a:p>
         </p:txBody>
@@ -6857,8 +6875,8 @@
         </p:nvSpPr>
         <p:spPr bwMode="auto">
           <a:xfrm>
-            <a:off x="18826986" y="6866513"/>
-            <a:ext cx="14709649" cy="8248412"/>
+            <a:off x="18826986" y="6858000"/>
+            <a:ext cx="14709649" cy="4206240"/>
           </a:xfrm>
           <a:prstGeom prst="rect">
             <a:avLst/>
@@ -6873,7 +6891,7 @@
         </p:spPr>
         <p:txBody>
           <a:bodyPr wrap="square" lIns="182880" tIns="182880" rIns="182880" bIns="182880">
-            <a:spAutoFit/>
+            <a:normAutofit/>
           </a:bodyPr>
           <a:lstStyle>
             <a:lvl1pPr defTabSz="838200">
@@ -6979,24 +6997,16 @@
                 <a:spcPts val="0"/>
               </a:spcBef>
               <a:spcAft>
-                <a:spcPts val="0"/>
+                <a:spcPts val="600"/>
               </a:spcAft>
               <a:buFont typeface="Arial" panose="020B0604020202020204" pitchFamily="34" charset="0"/>
               <a:buChar char="•"/>
             </a:pPr>
             <a:r>
-              <a:rPr sz="3200">
-                <a:latin typeface="+mn-lt"/>
+              <a:rPr sz="2400">
+                <a:latin typeface="Calibri"/>
               </a:rPr>
-              <a:t>Four of five families leave every DVH criterion below the 1.0 Gy visibility threshold across the entire tested range. Spatial-resolution loss (P4) is the sole failure mode: its worst-affected criterion (larynx near-max dose) crosses 1.0 Gy at L2 (2.0/1.0-voxel blur) and reaches 2.84 Gy at L4 (+18.2% DVH score).</a:t>
-            </a:r>
-          </a:p>
-          <a:p>
-            <a:r>
-              <a:rPr sz="3200">
-                <a:latin typeface="+mn-lt"/>
-              </a:rPr>
-              <a:t>HU calibration shift becomes measurable only at an implausible 1000 HU bone offset (0.61 Gy, still sub-threshold). Noise, bias field, and dental streaks never exceed 0.34 Gy on any criterion, even beyond ACR-level severities.</a:t>
+              <a:t>Four of five perturbation families left every DVH criterion below the 1.0 Gy visibility threshold across the full tested range. Spatial-resolution loss (P4) was the sole family to exceed it: the most affected criterion, larynx near-maximum dose, crossed 1.0 Gy at severity level L2 (2.0/1.0-voxel Gaussian blur) and reached 2.84 Gy at L4 (+18.2% DVH score). Bone-weighted HU calibration shift became measurable only at an implausible 1000 HU offset (0.61 Gy, below threshold). Acquisition noise, bias field, and dental artifacts did not exceed 0.34 Gy on any criterion, even beyond ACR-level severities.</a:t>
             </a:r>
           </a:p>
         </p:txBody>
@@ -7026,8 +7036,8 @@
           <a:effectLst/>
         </p:spPr>
         <p:txBody>
-          <a:bodyPr lIns="182880" tIns="182880" rIns="182880" bIns="182880">
-            <a:noAutofit/>
+          <a:bodyPr lIns="182880" tIns="182880" rIns="182880" bIns="182880" wrap="square">
+            <a:normAutofit/>
           </a:bodyPr>
           <a:lstStyle>
             <a:lvl1pPr defTabSz="838200">
@@ -7133,30 +7143,40 @@
                 <a:spcPts val="0"/>
               </a:spcBef>
               <a:spcAft>
-                <a:spcPts val="0"/>
+                <a:spcPts val="600"/>
               </a:spcAft>
             </a:pPr>
             <a:r>
-              <a:rPr sz="3200">
-                <a:latin typeface="+mn-lt"/>
+              <a:rPr sz="2400">
+                <a:latin typeface="Calibri"/>
               </a:rPr>
-              <a:t>The model is robust to intensity-based CT variability — noise, calibration drift, bias field, dental streaks — through and beyond ACR-level severities, because these preserve the structural edges the network uses to localize organ boundaries.</a:t>
-            </a:r>
-          </a:p>
-          <a:p>
-            <a:r>
-              <a:rPr sz="3200">
-                <a:latin typeface="+mn-lt"/>
+              <a:t>The model was robust to intensity-based CT variability, including acquisition noise, calibration drift, bias field, and dental artifacts, at severities beyond typical clinical ranges. These perturbations preserve the structural boundaries the network uses to localize anatomy.</a:t>
+            </a:r>
+          </a:p>
+          <a:p>
+            <a:pPr>
+              <a:spcAft>
+                <a:spcPts val="600"/>
+              </a:spcAft>
+            </a:pPr>
+            <a:r>
+              <a:rPr sz="2400">
+                <a:latin typeface="Calibri"/>
               </a:rPr>
-              <a:t>Spatial-resolution loss removes exactly that edge content, producing boundary-localized dose errors that grow approximately linearly with blur and appear first in geometrically complex structures (larynx, parotids, mandible).</a:t>
-            </a:r>
-          </a:p>
-          <a:p>
-            <a:r>
-              <a:rPr sz="3200">
-                <a:latin typeface="+mn-lt"/>
+              <a:t>Spatial-resolution loss degrades this boundary information, producing spatially structured dose errors that increase approximately linearly with blur and appear first in geometrically complex structures such as the larynx, parotid glands, and mandible.</a:t>
+            </a:r>
+          </a:p>
+          <a:p>
+            <a:pPr>
+              <a:spcAft>
+                <a:spcPts val="600"/>
+              </a:spcAft>
+            </a:pPr>
+            <a:r>
+              <a:rPr sz="2400">
+                <a:latin typeface="Calibri"/>
               </a:rPr>
-              <a:t>Because realistic cross-scanner slice-thickness and reconstruction-kernel differences span the severities where P4 becomes visible, spatial resolution — not HU calibration — is the clinically relevant robustness risk.</a:t>
+              <a:t>Because realistic inter-scanner differences in slice thickness and reconstruction kernel span the severities at which resolution loss becomes clinically visible, spatial resolution, rather than intensity calibration, is the principal robustness concern for cross-institution deployment.</a:t>
             </a:r>
           </a:p>
         </p:txBody>
@@ -7186,8 +7206,8 @@
           <a:effectLst/>
         </p:spPr>
         <p:txBody>
-          <a:bodyPr lIns="182880" tIns="182880" rIns="182880" bIns="182880">
-            <a:spAutoFit/>
+          <a:bodyPr lIns="182880" tIns="182880" rIns="182880" bIns="182880" wrap="square">
+            <a:normAutofit/>
           </a:bodyPr>
           <a:lstStyle>
             <a:lvl1pPr defTabSz="838200">
@@ -7288,36 +7308,42 @@
             </a:lvl9pPr>
           </a:lstStyle>
           <a:p>
-            <a:pPr defTabSz="4023067"/>
-            <a:r>
-              <a:rPr sz="3200" b="1">
+            <a:pPr defTabSz="4023067">
+              <a:spcAft>
+                <a:spcPts val="600"/>
+              </a:spcAft>
+            </a:pPr>
+            <a:r>
+              <a:rPr sz="2400">
                 <a:latin typeface="Calibri"/>
               </a:rPr>
-              <a:t>Data set | OpenKBP head-and-neck cohort (Babier et al. 2021): 200 training / 40 test patients; 128³ CT with 10 OAR/PTV structures; dose normalized to a 70 Gy prescription.</a:t>
-            </a:r>
-          </a:p>
-          <a:p>
-            <a:r>
-              <a:rPr sz="3200" b="1">
+              <a:t>Dataset. The OpenKBP head-and-neck cohort (Babier et al., 2021) was used: 200 training and 40 test patients, each with a 128³ CT, ten organ-at-risk and target structures, and dose normalized to a 70 Gy prescription.</a:t>
+            </a:r>
+          </a:p>
+          <a:p>
+            <a:pPr>
+              <a:spcAft>
+                <a:spcPts val="600"/>
+              </a:spcAft>
+            </a:pPr>
+            <a:r>
+              <a:rPr sz="2400">
                 <a:latin typeface="Calibri"/>
               </a:rPr>
-              <a:t>Realistic perturbation model | Five families applied to the test-input CT at 5 severity levels each (26 conditions), ranges meeting or exceeding ACR CT-simulation QA:</a:t>
-            </a:r>
-          </a:p>
-          <a:p>
-            <a:r>
-              <a:rPr sz="3200" b="1">
+              <a:t>Perturbations. Five families were applied to the test-input CT at five severity levels each (26 conditions total), with parameter ranges meeting or exceeding ACR CT-simulation quality-assurance limits: P1 heteroscedastic acquisition noise; P2 bone-weighted HU calibration shift; P3 low-frequency bias field; P4 anisotropic spatial-resolution loss; P5 dental metal streak artifacts.</a:t>
+            </a:r>
+          </a:p>
+          <a:p>
+            <a:pPr>
+              <a:spcAft>
+                <a:spcPts val="600"/>
+              </a:spcAft>
+            </a:pPr>
+            <a:r>
+              <a:rPr sz="2400">
                 <a:latin typeface="Calibri"/>
               </a:rPr>
-              <a:t>  P1 heteroscedastic acquisition noise  •  P2 bone-weighted HU calibration shift  •  P3 low-frequency bias field  •  P4 anisotropic resolution loss (Gaussian blur)  •  P5 dental metal streak artifacts.</a:t>
-            </a:r>
-          </a:p>
-          <a:p>
-            <a:r>
-              <a:rPr sz="3200" b="1">
-                <a:latin typeface="Calibri"/>
-              </a:rPr>
-              <a:t>Impact = ΔDVH and ΔMAE vs each patient’s own clean-CT baseline prediction. Visibility threshold: cohort-mean shift on any DVH criterion &gt; 1.0 Gy.</a:t>
+              <a:t>Analysis. Impact was quantified as the change in DVH metrics and voxel-wise mean absolute error relative to each patient's unperturbed prediction. A level was deemed clinically visible when the cohort-mean shift in any DVH criterion exceeded 1.0 Gy.</a:t>
             </a:r>
           </a:p>
         </p:txBody>
@@ -7348,7 +7374,7 @@
         </p:spPr>
         <p:txBody>
           <a:bodyPr wrap="square" lIns="182880" tIns="182880" rIns="182880" bIns="182880">
-            <a:spAutoFit/>
+            <a:normAutofit/>
           </a:bodyPr>
           <a:lstStyle>
             <a:lvl1pPr defTabSz="838200">
@@ -7454,22 +7480,27 @@
                 <a:spcPts val="0"/>
               </a:spcBef>
               <a:spcAft>
-                <a:spcPts val="0"/>
+                <a:spcPts val="600"/>
               </a:spcAft>
             </a:pPr>
             <a:r>
-              <a:rPr sz="3200">
-                <a:latin typeface="+mn-lt"/>
+              <a:rPr sz="2400">
+                <a:latin typeface="Calibri"/>
               </a:rPr>
-              <a:t>A head-and-neck deep-learning dose predictor tolerates clinically realistic intensity CT perturbations but is systematically sensitive to spatial-resolution degradation, which becomes clinically visible (&gt;1 Gy on a DVH criterion) within the range of real cross-scanner variation.</a:t>
-            </a:r>
-          </a:p>
-          <a:p>
-            <a:r>
-              <a:rPr sz="3200">
-                <a:latin typeface="+mn-lt"/>
+              <a:t>A head-and-neck deep-learning dose prediction model tolerates clinically realistic intensity-based CT perturbations but is systematically sensitive to spatial-resolution degradation, which becomes clinically visible within the range of realistic inter-scanner variation.</a:t>
+            </a:r>
+          </a:p>
+          <a:p>
+            <a:pPr>
+              <a:spcAft>
+                <a:spcPts val="600"/>
+              </a:spcAft>
+            </a:pPr>
+            <a:r>
+              <a:rPr sz="2400">
+                <a:latin typeface="Calibri"/>
               </a:rPr>
-              <a:t>Multi-institution deployment QA should prioritize CT spatial-resolution and reconstruction-kernel consistency over intensity calibration; dose-level (not image-quality) metrics should gate CBCT / synthetic-CT quality.</a:t>
+              <a:t>Multi-institution quality assurance should prioritize CT spatial-resolution and reconstruction-kernel consistency, and dose-based rather than image-quality metrics should be used to assess CBCT and synthetic-CT suitability.</a:t>
             </a:r>
           </a:p>
         </p:txBody>
@@ -7499,8 +7530,8 @@
           <a:effectLst/>
         </p:spPr>
         <p:txBody>
-          <a:bodyPr lIns="182880" tIns="182880" rIns="182880" bIns="182880">
-            <a:spAutoFit/>
+          <a:bodyPr lIns="182880" tIns="182880" rIns="182880" bIns="182880" wrap="square">
+            <a:normAutofit/>
           </a:bodyPr>
           <a:lstStyle>
             <a:lvl1pPr defTabSz="838200">
@@ -7608,20 +7639,28 @@
               <a:spcBef>
                 <a:spcPts val="1200"/>
               </a:spcBef>
+              <a:spcAft>
+                <a:spcPts val="600"/>
+              </a:spcAft>
             </a:pPr>
             <a:r>
-              <a:rPr sz="3200">
-                <a:latin typeface="+mn-lt"/>
+              <a:rPr sz="2400">
+                <a:latin typeface="Calibri"/>
               </a:rPr>
-              <a:t>Deep-learning dose prediction supports automated and adaptive treatment planning, but a model trained at one site must generalize to CTs acquired elsewhere — different scanners, kernels, dose levels, and artifacts. Unlike worst-case adversarial attacks, these are benign, physically realistic sources of image variability.</a:t>
-            </a:r>
-          </a:p>
-          <a:p>
-            <a:r>
-              <a:rPr sz="3200">
-                <a:latin typeface="+mn-lt"/>
+              <a:t>Deep-learning dose prediction is increasingly used to support automated and adaptive treatment planning. A model trained at one institution must generalize to CT images acquired under different conditions, including variation in scanner hardware, reconstruction kernel, dose level, and imaging artifacts. In contrast to worst-case adversarial perturbations, these represent benign, physically plausible sources of image variability.</a:t>
+            </a:r>
+          </a:p>
+          <a:p>
+            <a:pPr>
+              <a:spcAft>
+                <a:spcPts val="600"/>
+              </a:spcAft>
+            </a:pPr>
+            <a:r>
+              <a:rPr sz="2400">
+                <a:latin typeface="Calibri"/>
               </a:rPr>
-              <a:t>We ask a clinically framed question: how much CT degradation can a dose-prediction model tolerate before its errors become clinically visible? We answer it per perturbation family, identifying which CT-quality factors actually matter for safe multi-institution deployment.</a:t>
+              <a:t>This study characterizes the sensitivity of a head-and-neck dose prediction model to five families of clinically realistic CT perturbations and determines the severity at which each produces clinically significant changes in predicted dose, in order to identify the CT image-quality factors relevant to safe multi-institution deployment.</a:t>
             </a:r>
           </a:p>
         </p:txBody>
@@ -7652,7 +7691,7 @@
         </p:spPr>
         <p:txBody>
           <a:bodyPr wrap="square" lIns="182880" tIns="182880" rIns="182880" bIns="182880">
-            <a:spAutoFit/>
+            <a:normAutofit/>
           </a:bodyPr>
           <a:lstStyle>
             <a:lvl1pPr marL="419100" indent="-419100" defTabSz="838200">
@@ -7755,32 +7794,42 @@
           <a:p>
             <a:pPr marL="457200" indent="-457200">
               <a:spcAft>
-                <a:spcPct val="50000"/>
+                <a:spcPts val="600"/>
               </a:spcAft>
               <a:buFont typeface="+mj-lt"/>
               <a:buAutoNum type="arabicPeriod"/>
             </a:pPr>
             <a:r>
-              <a:rPr sz="2400">
-                <a:latin typeface="+mn-lt"/>
+              <a:rPr sz="2000">
+                <a:latin typeface="Calibri"/>
               </a:rPr>
               <a:t>1. Babier A, Mahon R, McNiven A, Diamant A, Chan TCY. Med Phys. 2021;48:4932-4948 (OpenKBP).</a:t>
             </a:r>
           </a:p>
           <a:p>
-            <a:r>
-              <a:rPr sz="2400">
-                <a:latin typeface="+mn-lt"/>
+            <a:pPr>
+              <a:spcAft>
+                <a:spcPts val="600"/>
+              </a:spcAft>
+            </a:pPr>
+            <a:r>
+              <a:rPr sz="2000">
+                <a:latin typeface="Calibri"/>
               </a:rPr>
               <a:t>2. Gao Y, et al. Phys Med Biol. 2025;70:115006.</a:t>
             </a:r>
           </a:p>
           <a:p>
-            <a:r>
-              <a:rPr sz="2400">
-                <a:latin typeface="+mn-lt"/>
+            <a:pPr>
+              <a:spcAft>
+                <a:spcPts val="600"/>
+              </a:spcAft>
+            </a:pPr>
+            <a:r>
+              <a:rPr sz="2000">
+                <a:latin typeface="Calibri"/>
               </a:rPr>
-              <a:t>3. American College of Radiology. CT Quality Control / Accreditation guidelines.</a:t>
+              <a:t>3. American College of Radiology. CT Quality Control and Accreditation guidelines.</a:t>
             </a:r>
           </a:p>
         </p:txBody>
@@ -8026,8 +8075,8 @@
         </p:nvSpPr>
         <p:spPr bwMode="auto">
           <a:xfrm>
-            <a:off x="18942352" y="27432000"/>
-            <a:ext cx="14866609" cy="1561960"/>
+            <a:off x="18836640" y="25338841"/>
+            <a:ext cx="14630400" cy="1554480"/>
           </a:xfrm>
           <a:prstGeom prst="rect">
             <a:avLst/>
@@ -8068,7 +8117,7 @@
         </p:spPr>
         <p:txBody>
           <a:bodyPr wrap="square" lIns="83814" tIns="41907" rIns="83814" bIns="41907">
-            <a:spAutoFit/>
+            <a:normAutofit/>
           </a:bodyPr>
           <a:lstStyle>
             <a:lvl1pPr defTabSz="4022725">
@@ -8169,11 +8218,16 @@
             </a:lvl9pPr>
           </a:lstStyle>
           <a:p>
-            <a:r>
-              <a:rPr sz="2400">
+            <a:pPr>
+              <a:spcAft>
+                <a:spcPts val="600"/>
+              </a:spcAft>
+            </a:pPr>
+            <a:r>
+              <a:rPr sz="1800">
                 <a:latin typeface="Calibri"/>
               </a:rPr>
-              <a:t>Figure 2. Worst-case per-criterion DVH shift (Gy) vs severity for each family, with the 1.0 Gy clinical-visibility line. P4 (resolution) crosses between L1 and L2 and keeps climbing; all other families remain near the floor.</a:t>
+              <a:t>Figure 2. Maximum per-criterion DVH shift versus perturbation severity for each family; the dashed line marks the 1.0 Gy clinical-visibility threshold. Spatial-resolution loss (P4) crosses the threshold between levels L1 and L2; all other families remain near zero.</a:t>
             </a:r>
           </a:p>
         </p:txBody>
@@ -8205,7 +8259,7 @@
         </p:spPr>
         <p:txBody>
           <a:bodyPr spcFirstLastPara="1" wrap="square" lIns="91425" tIns="91425" rIns="91425" bIns="91425" anchor="t" anchorCtr="0">
-            <a:noAutofit/>
+            <a:normAutofit/>
           </a:bodyPr>
           <a:lstStyle/>
           <a:p>
@@ -8214,12 +8268,12 @@
                 <a:spcPts val="0"/>
               </a:spcBef>
               <a:spcAft>
-                <a:spcPts val="0"/>
+                <a:spcPts val="600"/>
               </a:spcAft>
               <a:buNone/>
             </a:pPr>
             <a:r>
-              <a:rPr sz="8000" b="1">
+              <a:rPr sz="7200">
                 <a:latin typeface="Calibri"/>
               </a:rPr>
               <a:t>Robustness of Deep-Learning Dose Prediction in Head-and-Neck Radiotherapy to Clinically Realistic CT Perturbations</a:t>
@@ -8256,31 +8310,59 @@
         </p:spPr>
         <p:txBody>
           <a:bodyPr wrap="square">
-            <a:spAutoFit/>
+            <a:normAutofit/>
           </a:bodyPr>
           <a:lstStyle/>
           <a:p>
-            <a:r>
-              <a:rPr sz="3600">
+            <a:pPr>
+              <a:spcAft>
+                <a:spcPts val="600"/>
+              </a:spcAft>
+            </a:pPr>
+            <a:r>
+              <a:rPr sz="2400">
                 <a:latin typeface="Calibri"/>
               </a:rPr>
-              <a:t>Deep-learning dose prediction is nearing clinical deployment, where models trained at one institution encounter CTs from different scanners, reconstruction kernels, and imaging practices. We stress-tested a 3D U-Net head-and-neck dose predictor against five families of clinically realistic CT perturbations — acquisition noise, HU calibration shift, low-frequency bias field, spatial-resolution loss, and dental streak artifacts — across 26 conditions on 40 test patients, at severities meeting or exceeding ACR CT-simulation QA.</a:t>
-            </a:r>
-          </a:p>
-          <a:p>
-            <a:r>
-              <a:rPr sz="3600">
+              <a:t>Purpose. Deep-learning dose prediction models are increasingly deployed across institutions, where they encounter CT images from different scanners, reconstruction kernels, and acquisition protocols. This study quantifies the robustness of a head-and-neck dose prediction model to five families of clinically realistic CT perturbations and identifies the image-quality factors that materially affect predicted dose.</a:t>
+            </a:r>
+          </a:p>
+          <a:p>
+            <a:pPr>
+              <a:spcAft>
+                <a:spcPts val="600"/>
+              </a:spcAft>
+            </a:pPr>
+            <a:r>
+              <a:rPr sz="2400">
                 <a:latin typeface="Calibri"/>
               </a:rPr>
-              <a:t>Defining a level as “clinically visible” when the cohort-mean change in any DVH criterion exceeds 1.0 Gy from each patient’s own baseline, four of five families never reach visibility. Only spatial-resolution loss does — crossing 1.0 Gy at a clinically realistic severity (~2 mm-equivalent blur) and rising to 2.84 Gy at the larynx (+18.2% DVH).</a:t>
-            </a:r>
-          </a:p>
-          <a:p>
-            <a:r>
-              <a:rPr sz="3600">
+              <a:t>Methods. A 3D U-Net dose predictor was evaluated on 40 test patients under 26 CT conditions spanning acquisition noise, HU calibration shift, low-frequency bias field, spatial-resolution loss, and dental streak artifacts, at severities meeting or exceeding ACR CT-simulation quality-assurance limits. A perturbation level was defined as clinically visible when the cohort-mean change in any dose-volume-histogram (DVH) criterion exceeded 1.0 Gy relative to each patient's unperturbed prediction.</a:t>
+            </a:r>
+          </a:p>
+          <a:p>
+            <a:pPr>
+              <a:spcAft>
+                <a:spcPts val="600"/>
+              </a:spcAft>
+            </a:pPr>
+            <a:r>
+              <a:rPr sz="2400">
                 <a:latin typeface="Calibri"/>
               </a:rPr>
-              <a:t>Cross-institution deployment QA should therefore prioritize CT spatial-resolution and reconstruction-kernel consistency over intensity calibration.</a:t>
+              <a:t>Results. Four of five perturbation families produced no clinically visible change at any tested severity. Spatial-resolution degradation was the only family to exceed the 1.0 Gy threshold, reaching 2.84 Gy at the larynx (+18.2% DVH score) at the highest severity.</a:t>
+            </a:r>
+          </a:p>
+          <a:p>
+            <a:pPr>
+              <a:spcAft>
+                <a:spcPts val="600"/>
+              </a:spcAft>
+            </a:pPr>
+            <a:r>
+              <a:rPr sz="2400">
+                <a:latin typeface="Calibri"/>
+              </a:rPr>
+              <a:t>Conclusions. The model is robust to intensity-based CT variability but sensitive to spatial-resolution loss. Multi-institution quality assurance should prioritize CT spatial-resolution and reconstruction-kernel consistency.</a:t>
             </a:r>
           </a:p>
         </p:txBody>
@@ -8316,8 +8398,8 @@
           <a:effectLst/>
         </p:spPr>
         <p:txBody>
-          <a:bodyPr lIns="182880" tIns="182880" rIns="182880" bIns="182880">
-            <a:spAutoFit/>
+          <a:bodyPr lIns="182880" tIns="182880" rIns="182880" bIns="182880" wrap="square">
+            <a:normAutofit/>
           </a:bodyPr>
           <a:lstStyle>
             <a:lvl1pPr defTabSz="838200">
@@ -8423,14 +8505,14 @@
                 <a:spcPts val="0"/>
               </a:spcBef>
               <a:spcAft>
-                <a:spcPts val="0"/>
+                <a:spcPts val="600"/>
               </a:spcAft>
             </a:pPr>
             <a:r>
-              <a:rPr sz="3600" b="1">
-                <a:latin typeface="+mn-lt"/>
+              <a:rPr sz="2200">
+                <a:latin typeface="Calibri"/>
               </a:rPr>
-              <a:t>Dose Prediction Model | 3D U-Net with squeeze-and-excitation blocks; masked MAE loss with 4× PTV weighting. Baseline DVH score 2.54, dose score 3.73 Gy.</a:t>
+              <a:t>Model. A 3D U-Net with squeeze-and-excitation blocks was trained with a masked mean-absolute-error loss and 4× planning-target-volume weighting (baseline DVH score 2.54; dose score 3.73 Gy).</a:t>
             </a:r>
           </a:p>
         </p:txBody>
@@ -8497,7 +8579,7 @@
         </p:spPr>
         <p:txBody>
           <a:bodyPr wrap="square" lIns="182880" tIns="182880" rIns="182880" bIns="182880">
-            <a:spAutoFit/>
+            <a:normAutofit/>
           </a:bodyPr>
           <a:lstStyle>
             <a:lvl1pPr defTabSz="838200">
@@ -8603,12 +8685,12 @@
                 <a:spcPts val="0"/>
               </a:spcBef>
               <a:spcAft>
-                <a:spcPts val="0"/>
+                <a:spcPts val="600"/>
               </a:spcAft>
             </a:pPr>
             <a:r>
-              <a:rPr sz="3600" b="1">
-                <a:latin typeface="+mn-lt"/>
+              <a:rPr sz="2200">
+                <a:latin typeface="Calibri"/>
               </a:rPr>
               <a:t/>
             </a:r>
@@ -8639,12 +8721,17 @@
         </p:spPr>
         <p:txBody>
           <a:bodyPr wrap="square" rtlCol="0">
-            <a:spAutoFit/>
+            <a:normAutofit/>
           </a:bodyPr>
           <a:lstStyle/>
           <a:p>
-            <a:r>
-              <a:rPr>
+            <a:pPr>
+              <a:spcAft>
+                <a:spcPts val="600"/>
+              </a:spcAft>
+            </a:pPr>
+            <a:r>
+              <a:rPr sz="1800">
                 <a:latin typeface="Calibri"/>
               </a:rPr>
               <a:t/>
@@ -8668,8 +8755,8 @@
         </p:nvSpPr>
         <p:spPr bwMode="auto">
           <a:xfrm>
-            <a:off x="19054098" y="34930080"/>
-            <a:ext cx="14866609" cy="2300624"/>
+            <a:off x="18836640" y="33166922"/>
+            <a:ext cx="14630400" cy="1554480"/>
           </a:xfrm>
           <a:prstGeom prst="rect">
             <a:avLst/>
@@ -8710,7 +8797,7 @@
         </p:spPr>
         <p:txBody>
           <a:bodyPr wrap="square" lIns="83814" tIns="41907" rIns="83814" bIns="41907">
-            <a:spAutoFit/>
+            <a:normAutofit/>
           </a:bodyPr>
           <a:lstStyle>
             <a:lvl1pPr defTabSz="4022725">
@@ -8811,11 +8898,16 @@
             </a:lvl9pPr>
           </a:lstStyle>
           <a:p>
-            <a:r>
-              <a:rPr sz="2400">
+            <a:pPr>
+              <a:spcAft>
+                <a:spcPts val="600"/>
+              </a:spcAft>
+            </a:pPr>
+            <a:r>
+              <a:rPr sz="1800">
                 <a:latin typeface="Calibri"/>
               </a:rPr>
-              <a:t>Figure 3. Predicted dose (top) and difference-from-baseline maps (bottom) per perturbation. Resolution degradation produces spatially structured dose errors concentrated at organ boundaries; other families are near-zero.</a:t>
+              <a:t>Figure 3. Predicted dose (top row) and difference-from-baseline maps (bottom row) for each perturbation family. Spatial-resolution loss produces spatially structured dose errors concentrated at organ boundaries; other families produce negligible change.</a:t>
             </a:r>
           </a:p>
         </p:txBody>
@@ -9024,7 +9116,7 @@
         </p:spPr>
         <p:txBody>
           <a:bodyPr wrap="square" lIns="182880" tIns="182880" rIns="182880" bIns="182880">
-            <a:spAutoFit/>
+            <a:normAutofit/>
           </a:bodyPr>
           <a:lstStyle>
             <a:lvl1pPr defTabSz="838200">
@@ -9130,14 +9222,14 @@
                 <a:spcPts val="0"/>
               </a:spcBef>
               <a:spcAft>
-                <a:spcPts val="0"/>
+                <a:spcPts val="600"/>
               </a:spcAft>
             </a:pPr>
             <a:r>
-              <a:rPr sz="3200">
-                <a:latin typeface="+mn-lt"/>
+              <a:rPr sz="2400">
+                <a:latin typeface="Calibri"/>
               </a:rPr>
-              <a:t>Extend the battery to CBCT-characteristic degradations (scatter/cupping, ring artifacts, limited-FOV truncation) for online adaptive-RT commissioning tolerances; provable (certified) and conformal per-patient DVH bounds under bounded CT perturbation; and training-time augmentation to restore the resolution margin.</a:t>
+              <a:t>Planned extensions include CBCT-characteristic degradations (scatter and cupping, ring artifacts, limited-field-of-view truncation) to establish commissioning tolerances for online adaptive radiotherapy; distribution-free (conformal) and certified per-patient DVH prediction intervals under bounded CT perturbation; and training-time augmentation to improve resolution robustness.</a:t>
             </a:r>
           </a:p>
         </p:txBody>
@@ -9158,8 +9250,8 @@
         </p:blipFill>
         <p:spPr>
           <a:xfrm>
-            <a:off x="18928080" y="13990320"/>
-            <a:ext cx="14813280" cy="6074272"/>
+            <a:off x="18836640" y="11521440"/>
+            <a:ext cx="14630400" cy="5999281"/>
           </a:xfrm>
           <a:prstGeom prst="rect">
             <a:avLst/>
@@ -9182,7 +9274,7 @@
         </p:blipFill>
         <p:spPr>
           <a:xfrm>
-            <a:off x="21488400" y="21579840"/>
+            <a:off x="21351240" y="19349521"/>
             <a:ext cx="9601200" cy="5897880"/>
           </a:xfrm>
           <a:prstGeom prst="rect">
@@ -9206,8 +9298,8 @@
         </p:blipFill>
         <p:spPr>
           <a:xfrm>
-            <a:off x="18928080" y="28529280"/>
-            <a:ext cx="14813280" cy="6074272"/>
+            <a:off x="18836640" y="27076201"/>
+            <a:ext cx="14630400" cy="5999281"/>
           </a:xfrm>
           <a:prstGeom prst="rect">
             <a:avLst/>

</xml_diff>

<commit_message>
ASTRO handoff: official submitted title + all original figures listed; poster title updated to official
</commit_message>
<xml_diff>
--- a/reports/report2_ct_perturbation/astro_poster/ASTRO_79011_poster.pptx
+++ b/reports/report2_ct_perturbation/astro_poster/ASTRO_79011_poster.pptx
@@ -8273,10 +8273,10 @@
               <a:buNone/>
             </a:pPr>
             <a:r>
-              <a:rPr sz="7200">
+              <a:rPr sz="6000">
                 <a:latin typeface="Calibri"/>
               </a:rPr>
-              <a:t>Robustness of Deep-Learning Dose Prediction in Head-and-Neck Radiotherapy to Clinically Realistic CT Perturbations</a:t>
+              <a:t>Assessing the Generalizability and Robustness of Deep-Learning Dose Prediction in Head-and-Neck Radiotherapy to Clinically Realistic CT Perturbations</a:t>
             </a:r>
             <a:endParaRPr sz="8000" b="1" dirty="0">
               <a:solidFill>

</xml_diff>